<commit_message>
Final revision: add section descriptions, fix conclusions, update PPTX visualization slide
</commit_message>
<xml_diff>
--- a/reports/Presentacion_EDA_Titanic.pptx
+++ b/reports/Presentacion_EDA_Titanic.pptx
@@ -3844,24 +3844,7 @@
       <p:grpSpPr/>
       <p:sp>
         <p:nvSpPr>
-          <p:cNvPr id="2" name="Title 1"/>
-          <p:cNvSpPr>
-            <a:spLocks noGrp="1"/>
-          </p:cNvSpPr>
-          <p:nvPr>
-            <p:ph type="title"/>
-          </p:nvPr>
-        </p:nvSpPr>
-        <p:spPr/>
-        <p:txBody>
-          <a:bodyPr/>
-          <a:lstStyle/>
-          <a:p/>
-        </p:txBody>
-      </p:sp>
-      <p:sp>
-        <p:nvSpPr>
-          <p:cNvPr id="3" name="TextBox 2"/>
+          <p:cNvPr id="2" name="TextBox 1"/>
           <p:cNvSpPr txBox="1"/>
           <p:nvPr/>
         </p:nvSpPr>
@@ -3895,7 +3878,7 @@
       </p:sp>
       <p:sp>
         <p:nvSpPr>
-          <p:cNvPr id="4" name="Rectangle 3"/>
+          <p:cNvPr id="3" name="Rectangle 2"/>
           <p:cNvSpPr/>
           <p:nvPr/>
         </p:nvSpPr>
@@ -3938,14 +3921,14 @@
       </p:sp>
       <p:sp>
         <p:nvSpPr>
-          <p:cNvPr id="5" name="TextBox 4"/>
+          <p:cNvPr id="4" name="TextBox 3"/>
           <p:cNvSpPr txBox="1"/>
           <p:nvPr/>
         </p:nvSpPr>
         <p:spPr>
           <a:xfrm>
             <a:off x="274320" y="960120"/>
-            <a:ext cx="6217920" cy="5669280"/>
+            <a:ext cx="6035040" cy="5669280"/>
           </a:xfrm>
           <a:prstGeom prst="rect">
             <a:avLst/>
@@ -3965,29 +3948,18 @@
                 </a:solidFill>
                 <a:latin typeface="Consolas"/>
               </a:rPr>
-              <a:t>Histograma EDAD:</a:t>
-            </a:r>
-          </a:p>
-          <a:p>
-            <a:r>
-              <a:rPr sz="1400" b="0">
-                <a:solidFill>
-                  <a:srgbClr val="00FF41"/>
-                </a:solidFill>
-                <a:latin typeface="Consolas"/>
-              </a:rPr>
-              <a:t>  Distribucion aproximadamente normal (sesgo leve). Pico central: 20-35 anos.</a:t>
-            </a:r>
-          </a:p>
-          <a:p>
-            <a:r>
-              <a:rPr sz="1400" b="0">
-                <a:solidFill>
-                  <a:srgbClr val="00FF41"/>
-                </a:solidFill>
-                <a:latin typeface="Consolas"/>
-              </a:rPr>
-              <a:t>  Indica una mayoria de pasajeros en edad productiva.</a:t>
+              <a:t>Countplot (variable Y - SOBREVIVIO):</a:t>
+            </a:r>
+          </a:p>
+          <a:p>
+            <a:r>
+              <a:rPr sz="1400" b="0">
+                <a:solidFill>
+                  <a:srgbClr val="00FF41"/>
+                </a:solidFill>
+                <a:latin typeface="Consolas"/>
+              </a:rPr>
+              <a:t>  Desequilibrio moderado 61.6% / 38.4% — aceptable para modelado sin sobremuestreo.</a:t>
             </a:r>
           </a:p>
           <a:p/>
@@ -3999,29 +3971,29 @@
                 </a:solidFill>
                 <a:latin typeface="Consolas"/>
               </a:rPr>
-              <a:t>Diagrama de Dispersion (EDAD vs TARIFA):</a:t>
-            </a:r>
-          </a:p>
-          <a:p>
-            <a:r>
-              <a:rPr sz="1400" b="0">
-                <a:solidFill>
-                  <a:srgbClr val="00FF41"/>
-                </a:solidFill>
-                <a:latin typeface="Consolas"/>
-              </a:rPr>
-              <a:t>  Los sobrevivientes (verde) se concentran en tarifas altas, independiente de la edad.</a:t>
-            </a:r>
-          </a:p>
-          <a:p>
-            <a:r>
-              <a:rPr sz="1400" b="0">
-                <a:solidFill>
-                  <a:srgbClr val="00FF41"/>
-                </a:solidFill>
-                <a:latin typeface="Consolas"/>
-              </a:rPr>
-              <a:t>  Confirma que la TARIFA es mejor predictor que la EDAD.</a:t>
+              <a:t>Scatter plot 2D (EDAD vs TARIFA):</a:t>
+            </a:r>
+          </a:p>
+          <a:p>
+            <a:r>
+              <a:rPr sz="1400" b="0">
+                <a:solidFill>
+                  <a:srgbClr val="00FF41"/>
+                </a:solidFill>
+                <a:latin typeface="Consolas"/>
+              </a:rPr>
+              <a:t>  Los supervivientes (verde) se concentran en tarifas altas, sin importar la edad.</a:t>
+            </a:r>
+          </a:p>
+          <a:p>
+            <a:r>
+              <a:rPr sz="1400" b="0">
+                <a:solidFill>
+                  <a:srgbClr val="00FF41"/>
+                </a:solidFill>
+                <a:latin typeface="Consolas"/>
+              </a:rPr>
+              <a:t>  Confirma que TARIFA es mejor predictor que EDAD individualmente.</a:t>
             </a:r>
           </a:p>
           <a:p/>
@@ -4033,29 +4005,29 @@
                 </a:solidFill>
                 <a:latin typeface="Consolas"/>
               </a:rPr>
-              <a:t>Boxplot (TARIFA por SOBREVIVIO):</a:t>
-            </a:r>
-          </a:p>
-          <a:p>
-            <a:r>
-              <a:rPr sz="1400" b="0">
-                <a:solidFill>
-                  <a:srgbClr val="00FF41"/>
-                </a:solidFill>
-                <a:latin typeface="Consolas"/>
-              </a:rPr>
-              <a:t>  La mediana de tarifa de supervivientes (~26 GBP) es MAYOR que la de no supervivientes</a:t>
-            </a:r>
-          </a:p>
-          <a:p>
-            <a:r>
-              <a:rPr sz="1400" b="0">
-                <a:solidFill>
-                  <a:srgbClr val="00FF41"/>
-                </a:solidFill>
-                <a:latin typeface="Consolas"/>
-              </a:rPr>
-              <a:t>  (~10 GBP) — diferencia altamente significativa.</a:t>
+              <a:t>Histograma (EDAD):</a:t>
+            </a:r>
+          </a:p>
+          <a:p>
+            <a:r>
+              <a:rPr sz="1400" b="0">
+                <a:solidFill>
+                  <a:srgbClr val="00FF41"/>
+                </a:solidFill>
+                <a:latin typeface="Consolas"/>
+              </a:rPr>
+              <a:t>  Distribucion aproximadamente normal, pico en 20-35 anos.</a:t>
+            </a:r>
+          </a:p>
+          <a:p>
+            <a:r>
+              <a:rPr sz="1400" b="0">
+                <a:solidFill>
+                  <a:srgbClr val="00FF41"/>
+                </a:solidFill>
+                <a:latin typeface="Consolas"/>
+              </a:rPr>
+              <a:t>  La mayoria de pasajeros era poblacion adulta joven.</a:t>
             </a:r>
           </a:p>
           <a:p/>
@@ -4067,40 +4039,51 @@
                 </a:solidFill>
                 <a:latin typeface="Consolas"/>
               </a:rPr>
-              <a:t>Distribucion de Y (SOBREVIVIO):</a:t>
-            </a:r>
-          </a:p>
-          <a:p>
-            <a:r>
-              <a:rPr sz="1400" b="0">
-                <a:solidFill>
-                  <a:srgbClr val="00FF41"/>
-                </a:solidFill>
-                <a:latin typeface="Consolas"/>
-              </a:rPr>
-              <a:t>  Desequilibrio moderado 61.6% / 38.4% — no requiere tecnicas de sobremuestreo obligatorio.</a:t>
+              <a:t>Boxplots (TARIFA y EDAD segun SOBREVIVIO):</a:t>
+            </a:r>
+          </a:p>
+          <a:p>
+            <a:r>
+              <a:rPr sz="1400" b="0">
+                <a:solidFill>
+                  <a:srgbClr val="00FF41"/>
+                </a:solidFill>
+                <a:latin typeface="Consolas"/>
+              </a:rPr>
+              <a:t>  La mediana de TARIFA de supervivientes (~26 GBP) es 2.5x mayor que la de no</a:t>
+            </a:r>
+          </a:p>
+          <a:p>
+            <a:r>
+              <a:rPr sz="1400" b="0">
+                <a:solidFill>
+                  <a:srgbClr val="00FF41"/>
+                </a:solidFill>
+                <a:latin typeface="Consolas"/>
+              </a:rPr>
+              <a:t>  supervivientes (~10 GBP) — diferencia altamente significativa y visualmente clara.</a:t>
             </a:r>
           </a:p>
         </p:txBody>
       </p:sp>
       <p:pic>
         <p:nvPicPr>
-          <p:cNvPr id="6" name="Picture 5" descr="E_visualizacion.png"/>
+          <p:cNvPr id="5" name="Picture 4" descr="viz_slide.png"/>
           <p:cNvPicPr>
             <a:picLocks noChangeAspect="1"/>
           </p:cNvPicPr>
           <p:nvPr/>
         </p:nvPicPr>
         <p:blipFill>
-          <a:blip r:embed="rId2"/>
+          <a:blip r:embed="rId3"/>
           <a:stretch>
             <a:fillRect/>
           </a:stretch>
         </p:blipFill>
         <p:spPr>
           <a:xfrm>
-            <a:off x="6583680" y="960120"/>
-            <a:ext cx="5394960" cy="1683469"/>
+            <a:off x="6492240" y="960120"/>
+            <a:ext cx="5394960" cy="1957902"/>
           </a:xfrm>
           <a:prstGeom prst="rect">
             <a:avLst/>

</xml_diff>